<commit_message>
Update prebooking model: 10 spots, Rs.1000 deposit, Rs.5500 balance on drop day
</commit_message>
<xml_diff>
--- a/NUUL_IVI_Pitch_Deck.pptx
+++ b/NUUL_IVI_Pitch_Deck.pptx
@@ -5625,7 +5625,7 @@
                 </a:solidFill>
                 <a:latin typeface="League Spartan"/>
               </a:rPr>
-              <a:t>50 spots</a:t>
+              <a:t>10 spots</a:t>
             </a:r>
           </a:p>
         </p:txBody>
@@ -5660,7 +5660,7 @@
                 </a:solidFill>
                 <a:latin typeface="Courier New"/>
               </a:rPr>
-              <a:t>PRE-BOOK WINDOW</a:t>
+              <a:t>₹1K DEPOSIT EACH</a:t>
             </a:r>
           </a:p>
         </p:txBody>
@@ -11362,7 +11362,7 @@
                 </a:solidFill>
                 <a:latin typeface="League Spartan"/>
               </a:rPr>
-              <a:t>50 Pre-Books</a:t>
+              <a:t>10 Spots</a:t>
             </a:r>
           </a:p>
         </p:txBody>
@@ -11397,7 +11397,7 @@
                 </a:solidFill>
                 <a:latin typeface="Courier New"/>
               </a:rPr>
-              <a:t>EARLY ACCESS SPOTS</a:t>
+              <a:t>₹1K DEPOSIT PRE-BOOK</a:t>
             </a:r>
           </a:p>
         </p:txBody>
@@ -12381,7 +12381,7 @@
                 <a:latin typeface="Calibri"/>
               </a:rPr>
               <a:t>Pre-booking OPENS
-50 spots, 72h window</a:t>
+10 spots · ₹1,000 deposit</a:t>
             </a:r>
           </a:p>
         </p:txBody>
@@ -12497,8 +12497,8 @@
                 </a:solidFill>
                 <a:latin typeface="Calibri"/>
               </a:rPr>
-              <a:t>Pre-books fulfilled
-+ remaining units live</a:t>
+              <a:t>Pay ₹5,500 balance
+90 units go live</a:t>
             </a:r>
           </a:p>
         </p:txBody>
@@ -13154,7 +13154,7 @@
                 </a:solidFill>
                 <a:latin typeface="Calibri"/>
               </a:rPr>
-              <a:t>D2C limited drops (scarcity model). Password-only access. 100 pieces per batch. 50 pre-book spots open 1 week before drop. Remaining 50 go live on drop day. No restock unless the batch earns it.</a:t>
+              <a:t>D2C limited drops. 100 pieces. 10 pre-book spots open at T-1W — ₹1,000 deposit secures your unit. Balance of ₹5,500 due on drop day. Remaining 90 units go live on drop day. No restock unless the batch earns it.</a:t>
             </a:r>
           </a:p>
         </p:txBody>
@@ -20271,7 +20271,7 @@
                 </a:solidFill>
                 <a:latin typeface="Calibri"/>
               </a:rPr>
-              <a:t>Pre-booking opens — 50 spots, 72h window. On drop day: remaining 50 units go live. Real-time unit counter. We find out.</a:t>
+              <a:t>Pre-booking opens — 10 spots, ₹1,000 deposit each. On drop day: pre-bookers pay ₹5,500 balance. Remaining 90 units go live. Real-time counter. We find out.</a:t>
             </a:r>
           </a:p>
         </p:txBody>

</xml_diff>